<commit_message>
Update project name to Cyclone Guard and refresh presentation with screenshots
</commit_message>
<xml_diff>
--- a/CycloneGuard_Project_Presentation.pptx
+++ b/CycloneGuard_Project_Presentation.pptx
@@ -3123,7 +3123,7 @@
           <a:lstStyle/>
           <a:p>
             <a:r>
-              <a:t>CycloneGuard: Predictive Disaster Intelligence</a:t>
+              <a:t>Cyclone Guard</a:t>
             </a:r>
           </a:p>
         </p:txBody>
@@ -3142,6 +3142,12 @@
         <p:txBody>
           <a:bodyPr/>
           <a:lstStyle/>
+          <a:p>
+            <a:r>
+              <a:t>Predictive safety dashboard for coastal communities</a:t>
+            </a:r>
+          </a:p>
+          <a:p/>
           <a:p>
             <a:r>
               <a:t>Team Aftershock</a:t>

</xml_diff>